<commit_message>
Update MapsAndObjectIntro slides for IntelliJ
</commit_message>
<xml_diff>
--- a/ClassMaterials/MapsAndObjectIntro/Slides/Part2-DocumentingCode.pptx
+++ b/ClassMaterials/MapsAndObjectIntro/Slides/Part2-DocumentingCode.pptx
@@ -424,7 +424,7 @@
           <a:p>
             <a:fld id="{73386005-8F80-1A49-87D1-22EBFA47E352}" type="datetimeFigureOut">
               <a:rPr lang="en-US" smtClean="0"/>
-              <a:t>3/14/2025</a:t>
+              <a:t>9/11/2026</a:t>
             </a:fld>
             <a:endParaRPr lang="en-US"/>
           </a:p>
@@ -1353,7 +1353,7 @@
           <a:p>
             <a:fld id="{5B07E745-2C70-2943-8487-A8F6E88ADF5E}" type="datetimeFigureOut">
               <a:rPr lang="en-US" smtClean="0"/>
-              <a:t>3/14/2025</a:t>
+              <a:t>9/11/2026</a:t>
             </a:fld>
             <a:endParaRPr lang="en-US"/>
           </a:p>
@@ -1521,7 +1521,7 @@
           <a:p>
             <a:fld id="{5B07E745-2C70-2943-8487-A8F6E88ADF5E}" type="datetimeFigureOut">
               <a:rPr lang="en-US" smtClean="0"/>
-              <a:t>3/14/2025</a:t>
+              <a:t>9/11/2026</a:t>
             </a:fld>
             <a:endParaRPr lang="en-US"/>
           </a:p>
@@ -1699,7 +1699,7 @@
           <a:p>
             <a:fld id="{5B07E745-2C70-2943-8487-A8F6E88ADF5E}" type="datetimeFigureOut">
               <a:rPr lang="en-US" smtClean="0"/>
-              <a:t>3/14/2025</a:t>
+              <a:t>9/11/2026</a:t>
             </a:fld>
             <a:endParaRPr lang="en-US"/>
           </a:p>
@@ -1867,7 +1867,7 @@
           <a:p>
             <a:fld id="{5B07E745-2C70-2943-8487-A8F6E88ADF5E}" type="datetimeFigureOut">
               <a:rPr lang="en-US" smtClean="0"/>
-              <a:t>3/14/2025</a:t>
+              <a:t>9/11/2026</a:t>
             </a:fld>
             <a:endParaRPr lang="en-US"/>
           </a:p>
@@ -2112,7 +2112,7 @@
           <a:p>
             <a:fld id="{5B07E745-2C70-2943-8487-A8F6E88ADF5E}" type="datetimeFigureOut">
               <a:rPr lang="en-US" smtClean="0"/>
-              <a:t>3/14/2025</a:t>
+              <a:t>9/11/2026</a:t>
             </a:fld>
             <a:endParaRPr lang="en-US"/>
           </a:p>
@@ -2397,7 +2397,7 @@
           <a:p>
             <a:fld id="{5B07E745-2C70-2943-8487-A8F6E88ADF5E}" type="datetimeFigureOut">
               <a:rPr lang="en-US" smtClean="0"/>
-              <a:t>3/14/2025</a:t>
+              <a:t>9/11/2026</a:t>
             </a:fld>
             <a:endParaRPr lang="en-US"/>
           </a:p>
@@ -2816,7 +2816,7 @@
           <a:p>
             <a:fld id="{5B07E745-2C70-2943-8487-A8F6E88ADF5E}" type="datetimeFigureOut">
               <a:rPr lang="en-US" smtClean="0"/>
-              <a:t>3/14/2025</a:t>
+              <a:t>9/11/2026</a:t>
             </a:fld>
             <a:endParaRPr lang="en-US"/>
           </a:p>
@@ -2933,7 +2933,7 @@
           <a:p>
             <a:fld id="{5B07E745-2C70-2943-8487-A8F6E88ADF5E}" type="datetimeFigureOut">
               <a:rPr lang="en-US" smtClean="0"/>
-              <a:t>3/14/2025</a:t>
+              <a:t>9/11/2026</a:t>
             </a:fld>
             <a:endParaRPr lang="en-US"/>
           </a:p>
@@ -3028,7 +3028,7 @@
           <a:p>
             <a:fld id="{5B07E745-2C70-2943-8487-A8F6E88ADF5E}" type="datetimeFigureOut">
               <a:rPr lang="en-US" smtClean="0"/>
-              <a:t>3/14/2025</a:t>
+              <a:t>9/11/2026</a:t>
             </a:fld>
             <a:endParaRPr lang="en-US"/>
           </a:p>
@@ -3303,7 +3303,7 @@
           <a:p>
             <a:fld id="{5B07E745-2C70-2943-8487-A8F6E88ADF5E}" type="datetimeFigureOut">
               <a:rPr lang="en-US" smtClean="0"/>
-              <a:t>3/14/2025</a:t>
+              <a:t>9/11/2026</a:t>
             </a:fld>
             <a:endParaRPr lang="en-US"/>
           </a:p>
@@ -3555,7 +3555,7 @@
           <a:p>
             <a:fld id="{5B07E745-2C70-2943-8487-A8F6E88ADF5E}" type="datetimeFigureOut">
               <a:rPr lang="en-US" smtClean="0"/>
-              <a:t>3/14/2025</a:t>
+              <a:t>9/11/2026</a:t>
             </a:fld>
             <a:endParaRPr lang="en-US"/>
           </a:p>
@@ -3766,7 +3766,7 @@
           <a:p>
             <a:fld id="{5B07E745-2C70-2943-8487-A8F6E88ADF5E}" type="datetimeFigureOut">
               <a:rPr lang="en-US" smtClean="0"/>
-              <a:t>3/14/2025</a:t>
+              <a:t>9/11/2026</a:t>
             </a:fld>
             <a:endParaRPr lang="en-US"/>
           </a:p>
@@ -4635,7 +4635,7 @@
             <a:effectLst/>
             <a:extLst>
               <a:ext uri="{C572A759-6A51-4108-AA02-DFA0A04FC94B}">
-                <ma14:wrappingTextBoxFlag xmlns:ma14="http://schemas.microsoft.com/office/mac/drawingml/2011/main" xmlns="" val="1"/>
+                <ma14:wrappingTextBoxFlag xmlns="" xmlns:ma14="http://schemas.microsoft.com/office/mac/drawingml/2011/main" val="1"/>
               </a:ext>
             </a:extLst>
           </p:spPr>
@@ -5405,7 +5405,7 @@
           </a:ln>
           <a:extLst>
             <a:ext uri="{C572A759-6A51-4108-AA02-DFA0A04FC94B}">
-              <ma14:wrappingTextBoxFlag xmlns:ma14="http://schemas.microsoft.com/office/mac/drawingml/2011/main" xmlns="" val="1"/>
+              <ma14:wrappingTextBoxFlag xmlns="" xmlns:ma14="http://schemas.microsoft.com/office/mac/drawingml/2011/main" val="1"/>
             </a:ext>
           </a:extLst>
         </p:spPr>
@@ -5593,7 +5593,7 @@
               <a:defRPr sz="1800"/>
             </a:pPr>
             <a:r>
-              <a:rPr sz="2900"/>
+              <a:rPr sz="2900" dirty="0"/>
               <a:t>Written in special comments: /** … */</a:t>
             </a:r>
           </a:p>
@@ -5608,7 +5608,7 @@
               <a:defRPr sz="1800"/>
             </a:pPr>
             <a:r>
-              <a:rPr sz="2900"/>
+              <a:rPr sz="2900" dirty="0"/>
               <a:t>Can come before:</a:t>
             </a:r>
           </a:p>
@@ -5623,7 +5623,7 @@
               <a:defRPr sz="1800"/>
             </a:pPr>
             <a:r>
-              <a:rPr sz="2500"/>
+              <a:rPr sz="2500" dirty="0"/>
               <a:t>Class declarations</a:t>
             </a:r>
           </a:p>
@@ -5638,7 +5638,7 @@
               <a:defRPr sz="1800"/>
             </a:pPr>
             <a:r>
-              <a:rPr sz="2500"/>
+              <a:rPr sz="2500" dirty="0"/>
               <a:t>Field declarations</a:t>
             </a:r>
           </a:p>
@@ -5653,7 +5653,7 @@
               <a:defRPr sz="1800"/>
             </a:pPr>
             <a:r>
-              <a:rPr sz="2500"/>
+              <a:rPr sz="2500" dirty="0"/>
               <a:t>Constructor declarations</a:t>
             </a:r>
           </a:p>
@@ -5668,7 +5668,7 @@
               <a:defRPr sz="1800"/>
             </a:pPr>
             <a:r>
-              <a:rPr sz="2500"/>
+              <a:rPr sz="2500" dirty="0"/>
               <a:t>Method declarations</a:t>
             </a:r>
           </a:p>
@@ -5683,8 +5683,12 @@
               <a:defRPr sz="1800"/>
             </a:pPr>
             <a:r>
-              <a:rPr sz="2900"/>
-              <a:t>Eclipse is your friend!</a:t>
+              <a:rPr lang="en-US" sz="2900" dirty="0"/>
+              <a:t>Your IDE</a:t>
+            </a:r>
+            <a:r>
+              <a:rPr sz="2900" dirty="0"/>
+              <a:t> is your friend!</a:t>
             </a:r>
           </a:p>
           <a:p>
@@ -5698,7 +5702,7 @@
               <a:defRPr sz="1800"/>
             </a:pPr>
             <a:r>
-              <a:rPr sz="2500"/>
+              <a:rPr sz="2500" dirty="0"/>
               <a:t>It will generate Javadoc comments automatically</a:t>
             </a:r>
           </a:p>
@@ -5713,7 +5717,7 @@
               <a:defRPr sz="1800"/>
             </a:pPr>
             <a:r>
-              <a:rPr sz="2500"/>
+              <a:rPr sz="2500" dirty="0"/>
               <a:t>It will notice when you start typing a Javadoc comment</a:t>
             </a:r>
           </a:p>
@@ -5803,7 +5807,7 @@
         </p:spPr>
         <p:txBody>
           <a:bodyPr>
-            <a:normAutofit/>
+            <a:normAutofit lnSpcReduction="10000"/>
           </a:bodyPr>
           <a:lstStyle/>
           <a:p>
@@ -5965,7 +5969,25 @@
             </a:pPr>
             <a:r>
               <a:rPr sz="2000" dirty="0"/>
-              <a:t>Use name completion in Eclipse, Ctrl-Space, to keep typing cost low and readability high</a:t>
+              <a:t>Use name completion </a:t>
+            </a:r>
+            <a:r>
+              <a:rPr lang="en-US" sz="2000" dirty="0"/>
+              <a:t>(</a:t>
+            </a:r>
+            <a:r>
+              <a:rPr lang="en-US" sz="2000" dirty="0">
+                <a:latin typeface="Consolas" panose="020B0609020204030204" pitchFamily="49" charset="0"/>
+              </a:rPr>
+              <a:t>Tab/Enter</a:t>
+            </a:r>
+            <a:r>
+              <a:rPr lang="en-US" sz="2000" dirty="0"/>
+              <a:t>)</a:t>
+            </a:r>
+            <a:r>
+              <a:rPr sz="2000" dirty="0"/>
+              <a:t> to keep typing cost low and readability high</a:t>
             </a:r>
             <a:endParaRPr sz="2800" dirty="0"/>
           </a:p>
@@ -5978,61 +6000,40 @@
             </a:pPr>
             <a:r>
               <a:rPr sz="2400" dirty="0"/>
-              <a:t>Use Ctrl-Shift-F in Eclipse to format your code.</a:t>
-            </a:r>
-          </a:p>
-        </p:txBody>
-      </p:sp>
-      <p:pic>
-        <p:nvPicPr>
-          <p:cNvPr id="174" name="image1.png"/>
-          <p:cNvPicPr/>
-          <p:nvPr/>
-        </p:nvPicPr>
-        <p:blipFill>
-          <a:blip r:embed="rId3"/>
-          <a:stretch>
-            <a:fillRect/>
-          </a:stretch>
-        </p:blipFill>
-        <p:spPr>
-          <a:xfrm>
-            <a:off x="2358287" y="5946274"/>
-            <a:ext cx="922021" cy="838200"/>
-          </a:xfrm>
-          <a:prstGeom prst="rect">
-            <a:avLst/>
-          </a:prstGeom>
-          <a:ln w="12700">
-            <a:miter lim="400000"/>
-          </a:ln>
-        </p:spPr>
-      </p:pic>
-      <p:pic>
-        <p:nvPicPr>
-          <p:cNvPr id="175" name="image2.png"/>
-          <p:cNvPicPr/>
-          <p:nvPr/>
-        </p:nvPicPr>
-        <p:blipFill>
-          <a:blip r:embed="rId4"/>
-          <a:stretch>
-            <a:fillRect/>
-          </a:stretch>
-        </p:blipFill>
-        <p:spPr>
-          <a:xfrm>
-            <a:off x="4876800" y="5943450"/>
-            <a:ext cx="1333500" cy="711201"/>
-          </a:xfrm>
-          <a:prstGeom prst="rect">
-            <a:avLst/>
-          </a:prstGeom>
-          <a:ln w="12700">
-            <a:miter lim="400000"/>
-          </a:ln>
-        </p:spPr>
-      </p:pic>
+              <a:t>Use </a:t>
+            </a:r>
+            <a:r>
+              <a:rPr lang="en-US" sz="2400" i="1" dirty="0"/>
+              <a:t>Code -&gt; Reformat Code</a:t>
+            </a:r>
+            <a:r>
+              <a:rPr sz="2400" dirty="0"/>
+              <a:t> </a:t>
+            </a:r>
+            <a:r>
+              <a:rPr lang="en-US" sz="2400" dirty="0"/>
+              <a:t>(</a:t>
+            </a:r>
+            <a:r>
+              <a:rPr lang="en-US" sz="2400" dirty="0" err="1">
+                <a:latin typeface="Consolas" panose="020B0609020204030204" pitchFamily="49" charset="0"/>
+              </a:rPr>
+              <a:t>Ctrl+Alt+L</a:t>
+            </a:r>
+            <a:r>
+              <a:rPr lang="en-US" sz="2400" dirty="0"/>
+              <a:t>) in IntelliJ </a:t>
+            </a:r>
+            <a:br>
+              <a:rPr lang="en-US" sz="2400" dirty="0"/>
+            </a:br>
+            <a:r>
+              <a:rPr sz="2400" dirty="0"/>
+              <a:t>to format your code.</a:t>
+            </a:r>
+          </a:p>
+        </p:txBody>
+      </p:sp>
       <p:grpSp>
         <p:nvGrpSpPr>
           <p:cNvPr id="6" name="Group 66"/>
@@ -6112,7 +6113,7 @@
             <a:effectLst/>
             <a:extLst>
               <a:ext uri="{C572A759-6A51-4108-AA02-DFA0A04FC94B}">
-                <ma14:wrappingTextBoxFlag xmlns:ma14="http://schemas.microsoft.com/office/mac/drawingml/2011/main" xmlns="" val="1"/>
+                <ma14:wrappingTextBoxFlag xmlns="" xmlns:ma14="http://schemas.microsoft.com/office/mac/drawingml/2011/main" val="1"/>
               </a:ext>
             </a:extLst>
           </p:spPr>
@@ -7032,18 +7033,18 @@
 </file>
 
 <file path=customXml/item1.xml><?xml version="1.0" encoding="utf-8"?>
-<p:properties xmlns:p="http://schemas.microsoft.com/office/2006/metadata/properties" xmlns:xsi="http://www.w3.org/2001/XMLSchema-instance" xmlns:pc="http://schemas.microsoft.com/office/infopath/2007/PartnerControls">
-  <documentManagement/>
-</p:properties>
-</file>
-
-<file path=customXml/item2.xml><?xml version="1.0" encoding="utf-8"?>
 <?mso-contentType ?>
 <FormTemplates xmlns="http://schemas.microsoft.com/sharepoint/v3/contenttype/forms">
   <Display>DocumentLibraryForm</Display>
   <Edit>DocumentLibraryForm</Edit>
   <New>DocumentLibraryForm</New>
 </FormTemplates>
+</file>
+
+<file path=customXml/item2.xml><?xml version="1.0" encoding="utf-8"?>
+<p:properties xmlns:p="http://schemas.microsoft.com/office/2006/metadata/properties" xmlns:xsi="http://www.w3.org/2001/XMLSchema-instance" xmlns:pc="http://schemas.microsoft.com/office/infopath/2007/PartnerControls">
+  <documentManagement/>
+</p:properties>
 </file>
 
 <file path=customXml/item3.xml><?xml version="1.0" encoding="utf-8"?>
@@ -7179,18 +7180,18 @@
 </file>
 
 <file path=customXml/itemProps1.xml><?xml version="1.0" encoding="utf-8"?>
-<ds:datastoreItem xmlns:ds="http://schemas.openxmlformats.org/officeDocument/2006/customXml" ds:itemID="{F97763C6-34AC-4EBA-9781-B781EFEF16EB}">
+<ds:datastoreItem xmlns:ds="http://schemas.openxmlformats.org/officeDocument/2006/customXml" ds:itemID="{F6D2D98F-7772-4D77-9EAD-84CA989E91DC}">
   <ds:schemaRefs>
-    <ds:schemaRef ds:uri="http://schemas.microsoft.com/office/2006/metadata/properties"/>
-    <ds:schemaRef ds:uri="http://schemas.microsoft.com/office/infopath/2007/PartnerControls"/>
+    <ds:schemaRef ds:uri="http://schemas.microsoft.com/sharepoint/v3/contenttype/forms"/>
   </ds:schemaRefs>
 </ds:datastoreItem>
 </file>
 
 <file path=customXml/itemProps2.xml><?xml version="1.0" encoding="utf-8"?>
-<ds:datastoreItem xmlns:ds="http://schemas.openxmlformats.org/officeDocument/2006/customXml" ds:itemID="{F6D2D98F-7772-4D77-9EAD-84CA989E91DC}">
+<ds:datastoreItem xmlns:ds="http://schemas.openxmlformats.org/officeDocument/2006/customXml" ds:itemID="{F97763C6-34AC-4EBA-9781-B781EFEF16EB}">
   <ds:schemaRefs>
-    <ds:schemaRef ds:uri="http://schemas.microsoft.com/sharepoint/v3/contenttype/forms"/>
+    <ds:schemaRef ds:uri="http://schemas.microsoft.com/office/2006/metadata/properties"/>
+    <ds:schemaRef ds:uri="http://schemas.microsoft.com/office/infopath/2007/PartnerControls"/>
   </ds:schemaRefs>
 </ds:datastoreItem>
 </file>

</xml_diff>